<commit_message>
Docs, paper, thesis plan, slides and status: J2 reached narrowly (0.503), hybrids up to 0.641
Co-Authored-By: Claude Opus 5.5 <noreply@anthropic.com>
</commit_message>
<xml_diff>
--- a/paper/soutenance/AML-GraphMiner_soutenance.pptx
+++ b/paper/soutenance/AML-GraphMiner_soutenance.pptx
@@ -3411,7 +3411,7 @@
                         <a:defRPr sz="1400"/>
                       </a:pPr>
                       <a:r>
-                        <a:t>0.340</a:t>
+                        <a:t>0.503</a:t>
                       </a:r>
                     </a:p>
                   </a:txBody>
@@ -3426,7 +3426,7 @@
                         <a:defRPr sz="1400"/>
                       </a:pPr>
                       <a:r>
-                        <a:t>0.562</a:t>
+                        <a:t>0.614</a:t>
                       </a:r>
                     </a:p>
                   </a:txBody>
@@ -3488,7 +3488,7 @@
                         <a:defRPr sz="1400"/>
                       </a:pPr>
                       <a:r>
-                        <a:t>0.340</a:t>
+                        <a:t>0.503</a:t>
                       </a:r>
                     </a:p>
                   </a:txBody>
@@ -3503,7 +3503,7 @@
                         <a:defRPr sz="1400"/>
                       </a:pPr>
                       <a:r>
-                        <a:t>0.545</a:t>
+                        <a:t>0.641</a:t>
                       </a:r>
                     </a:p>
                   </a:txBody>
@@ -3565,7 +3565,7 @@
                         <a:defRPr sz="1400"/>
                       </a:pPr>
                       <a:r>
-                        <a:t>0.340</a:t>
+                        <a:t>0.503</a:t>
                       </a:r>
                     </a:p>
                   </a:txBody>
@@ -3580,7 +3580,7 @@
                         <a:defRPr sz="1400"/>
                       </a:pPr>
                       <a:r>
-                        <a:t>0.527</a:t>
+                        <a:t>0.641</a:t>
                       </a:r>
                     </a:p>
                   </a:txBody>
@@ -3642,7 +3642,7 @@
                         <a:defRPr sz="1400"/>
                       </a:pPr>
                       <a:r>
-                        <a:t>0.147</a:t>
+                        <a:t>0.189</a:t>
                       </a:r>
                     </a:p>
                   </a:txBody>
@@ -3657,7 +3657,7 @@
                         <a:defRPr sz="1400"/>
                       </a:pPr>
                       <a:r>
-                        <a:t>0.186</a:t>
+                        <a:t>0.236</a:t>
                       </a:r>
                     </a:p>
                   </a:txBody>
@@ -3719,7 +3719,7 @@
                         <a:defRPr sz="1400"/>
                       </a:pPr>
                       <a:r>
-                        <a:t>0.147</a:t>
+                        <a:t>0.189</a:t>
                       </a:r>
                     </a:p>
                   </a:txBody>
@@ -3734,7 +3734,7 @@
                         <a:defRPr sz="1400"/>
                       </a:pPr>
                       <a:r>
-                        <a:t>0.113</a:t>
+                        <a:t>0.189</a:t>
                       </a:r>
                     </a:p>
                   </a:txBody>
@@ -3796,7 +3796,7 @@
                         <a:defRPr sz="1400"/>
                       </a:pPr>
                       <a:r>
-                        <a:t>0.147</a:t>
+                        <a:t>0.189</a:t>
                       </a:r>
                     </a:p>
                   </a:txBody>
@@ -3811,7 +3811,7 @@
                         <a:defRPr sz="1400"/>
                       </a:pPr>
                       <a:r>
-                        <a:t>0.168</a:t>
+                        <a:t>0.184</a:t>
                       </a:r>
                     </a:p>
                   </a:txBody>
@@ -4505,7 +4505,7 @@
               </a:defRPr>
             </a:pPr>
             <a:r>
-              <a:t>• Atteint : O1–O6, PR-AUC &gt; 0,5 sur HI-Small (GraphSAGE), interface web, hybride</a:t>
+              <a:t>• Atteint : O1–O6, J3 (GraphSAGE &gt; 0,5 sur HI-Small), interface web, hybride</a:t>
             </a:r>
           </a:p>
           <a:p>
@@ -4520,7 +4520,7 @@
               </a:defRPr>
             </a:pPr>
             <a:r>
-              <a:t>• Non atteint : J2 (motifs seuls &gt; 0,5) — motifs 0.340 sur HI-Small</a:t>
+              <a:t>• J2 atteint de justesse : motifs seuls 0.503 sur HI-Small (réglages et calibration choisis sur la validation)</a:t>
             </a:r>
           </a:p>
           <a:p>
@@ -4535,7 +4535,7 @@
               </a:defRPr>
             </a:pPr>
             <a:r>
-              <a:t>• LI-Small reste difficile : meilleur modèle 0.191 ± 0.007</a:t>
+              <a:t>• LI-Small reste difficile : meilleur modèle seul 0.191 ± 0.007, hybride forêt + motifs 0,236</a:t>
             </a:r>
           </a:p>
           <a:p>
@@ -6272,7 +6272,7 @@
               </a:defRPr>
             </a:pPr>
             <a:r>
-              <a:t>• Cycles jusqu'à 12 sauts, montants pouvant varier de −50 % à +50 % par saut (réglé sur la validation)</a:t>
+              <a:t>• Motif « stack » = relais A → B → C qui change de devise → nouveau détecteur de relais</a:t>
             </a:r>
           </a:p>
           <a:p>
@@ -6287,7 +6287,22 @@
               </a:defRPr>
             </a:pPr>
             <a:r>
-              <a:t>• Chaque alerte garde ses preuves : comptes, transactions, montants convertis</a:t>
+              <a:t>• Score d'alerte mal ordonné (fan-in inversé) → précision calibrée par tranche de score</a:t>
+            </a:r>
+          </a:p>
+          <a:p>
+            <a:pPr>
+              <a:spcAft>
+                <a:spcPts val="600"/>
+              </a:spcAft>
+              <a:defRPr sz="2000">
+                <a:solidFill>
+                  <a:srgbClr val="000000"/>
+                </a:solidFill>
+              </a:defRPr>
+            </a:pPr>
+            <a:r>
+              <a:t>• Résultat : PR-AUC des motifs 0.503 sur HI-Small (0,005 au départ), intervalle à 95 % 0,479–0,526</a:t>
             </a:r>
           </a:p>
         </p:txBody>

</xml_diff>

<commit_message>
L3 live: API and web interface deployed on Render (free plan)
https://aml-graphminer-demo.onrender.com/ui/ and /docs, created through the Render API in the
user's "aml-graphminer" project (Frankfurt, free plan, synthetic demo, uploads capped at 20 MB);
checked: /health, /ui/, /docs (OpenAPI 3.1), POST /score, /api/datasets. README, guide, status
and the review slide (L1, L3, L6 done) updated.

Co-Authored-By: Claude Opus 5.5 <noreply@anthropic.com>
</commit_message>
<xml_diff>
--- a/paper/soutenance/AML-GraphMiner_soutenance.pptx
+++ b/paper/soutenance/AML-GraphMiner_soutenance.pptx
@@ -10858,11 +10858,11 @@
             <a:avLst/>
           </a:prstGeom>
           <a:solidFill>
-            <a:srgbClr val="F5B700"/>
+            <a:srgbClr val="00A99D"/>
           </a:solidFill>
           <a:ln w="12700">
             <a:solidFill>
-              <a:srgbClr val="F5B700"/>
+              <a:srgbClr val="00A99D"/>
             </a:solidFill>
             <a:prstDash val="solid"/>
           </a:ln>
@@ -11180,11 +11180,11 @@
             <a:avLst/>
           </a:prstGeom>
           <a:solidFill>
-            <a:srgbClr val="F5B700"/>
+            <a:srgbClr val="00A99D"/>
           </a:solidFill>
           <a:ln w="12700">
             <a:solidFill>
-              <a:srgbClr val="F5B700"/>
+              <a:srgbClr val="00A99D"/>
             </a:solidFill>
             <a:prstDash val="solid"/>
           </a:ln>
@@ -11663,11 +11663,11 @@
             <a:avLst/>
           </a:prstGeom>
           <a:solidFill>
-            <a:srgbClr val="F5B700"/>
+            <a:srgbClr val="00A99D"/>
           </a:solidFill>
           <a:ln w="12700">
             <a:solidFill>
-              <a:srgbClr val="F5B700"/>
+              <a:srgbClr val="00A99D"/>
             </a:solidFill>
             <a:prstDash val="solid"/>
           </a:ln>

</xml_diff>

<commit_message>
Authors: the two students, everywhere a placeholder remained
pyproject.toml (shown on PyPI), CITATION.cff, LICENSE, the documentation,
the paper and the title slide of the defence now name Ahmed Ahmed Mahmoud
Abeideck and Saade Jaavar Boubacar; README gains an Authors section. The
project status lists what remains and compares the planned environment and
hardware with what was used.

Co-Authored-By: Claude Opus 5.5 <noreply@anthropic.com>
</commit_message>
<xml_diff>
--- a/paper/soutenance/AML-GraphMiner_soutenance.pptx
+++ b/paper/soutenance/AML-GraphMiner_soutenance.pptx
@@ -4415,7 +4415,27 @@
                 <a:ea typeface="Calibri" pitchFamily="34" charset="-122"/>
                 <a:cs typeface="Calibri" pitchFamily="34" charset="-120"/>
               </a:rPr>
-              <a:t>[Nom de l'étudiant] · Encadrant : Mohamedou El Ghotob Cheikh Tourad</a:t>
+              <a:t>Ahmed Ahmed Mahmoud Abeideck · Saade Jaavar Boubacar</a:t>
+            </a:r>
+            <a:endParaRPr lang="en-US" sz="1500" dirty="0"/>
+          </a:p>
+          <a:p>
+            <a:pPr indent="0" marL="0">
+              <a:spcAft>
+                <a:spcPts val="400"/>
+              </a:spcAft>
+              <a:buNone/>
+            </a:pPr>
+            <a:r>
+              <a:rPr lang="en-US" sz="1500" dirty="0">
+                <a:solidFill>
+                  <a:srgbClr val="C9D3E6"/>
+                </a:solidFill>
+                <a:latin typeface="Calibri" pitchFamily="34" charset="0"/>
+                <a:ea typeface="Calibri" pitchFamily="34" charset="-122"/>
+                <a:cs typeface="Calibri" pitchFamily="34" charset="-120"/>
+              </a:rPr>
+              <a:t>Encadrant : Mohamedou El Ghotob Cheikh Tourad</a:t>
             </a:r>
             <a:endParaRPr lang="en-US" sz="1500" dirty="0"/>
           </a:p>

</xml_diff>

<commit_message>
Academic supervisor's institution (ISCAE); title slide with both supervisors
Co-Authored-By: Claude Opus 5.5 <noreply@anthropic.com>
</commit_message>
<xml_diff>
--- a/paper/soutenance/AML-GraphMiner_soutenance.pptx
+++ b/paper/soutenance/AML-GraphMiner_soutenance.pptx
@@ -4347,8 +4347,8 @@
         </p:nvSpPr>
         <p:spPr>
           <a:xfrm>
-            <a:off x="640080" y="4206240"/>
-            <a:ext cx="6766560" cy="1097280"/>
+            <a:off x="640080" y="4114800"/>
+            <a:ext cx="6766560" cy="1463040"/>
           </a:xfrm>
           <a:prstGeom prst="rect">
             <a:avLst/>
@@ -4435,7 +4435,27 @@
                 <a:ea typeface="Calibri" pitchFamily="34" charset="-122"/>
                 <a:cs typeface="Calibri" pitchFamily="34" charset="-120"/>
               </a:rPr>
-              <a:t>Encadrant : Mohamedou El Ghotob Cheikh Tourad</a:t>
+              <a:t>Encadrant académique : Ahmed El Emine Sejad (ISCAE)</a:t>
+            </a:r>
+            <a:endParaRPr lang="en-US" sz="1500" dirty="0"/>
+          </a:p>
+          <a:p>
+            <a:pPr indent="0" marL="0">
+              <a:spcAft>
+                <a:spcPts val="400"/>
+              </a:spcAft>
+              <a:buNone/>
+            </a:pPr>
+            <a:r>
+              <a:rPr lang="en-US" sz="1500" dirty="0">
+                <a:solidFill>
+                  <a:srgbClr val="C9D3E6"/>
+                </a:solidFill>
+                <a:latin typeface="Calibri" pitchFamily="34" charset="0"/>
+                <a:ea typeface="Calibri" pitchFamily="34" charset="-122"/>
+                <a:cs typeface="Calibri" pitchFamily="34" charset="-120"/>
+              </a:rPr>
+              <a:t>Encadrant professionnel : Mohamedou El Ghotob Cheikh Tourad</a:t>
             </a:r>
             <a:endParaRPr lang="en-US" sz="1500" dirty="0"/>
           </a:p>

</xml_diff>